<commit_message>
small improvements and new smoke test run
</commit_message>
<xml_diff>
--- a/Slides.pptx
+++ b/Slides.pptx
@@ -21057,7 +21057,7 @@
           <p:nvPr>
             <p:extLst>
               <p:ext uri="{D42A27DB-BD31-4B8C-83A1-F6EECF244321}">
-                <p14:modId xmlns:p14="http://schemas.microsoft.com/office/powerpoint/2010/main" val="2670813078"/>
+                <p14:modId xmlns:p14="http://schemas.microsoft.com/office/powerpoint/2010/main" val="3117306702"/>
               </p:ext>
             </p:extLst>
           </p:nvPr>
@@ -22090,7 +22090,7 @@
                           <a:latin typeface="Arial"/>
                           <a:ea typeface="Arial"/>
                         </a:rPr>
-                        <a:t>1000 </a:t>
+                        <a:t>500 </a:t>
                       </a:r>
                       <a:endParaRPr lang="en-US" sz="2400" b="0" u="none" strike="noStrike" dirty="0">
                         <a:solidFill>
@@ -22147,7 +22147,7 @@
                           <a:latin typeface="Arial"/>
                           <a:ea typeface="Arial"/>
                         </a:rPr>
-                        <a:t>400 </a:t>
+                        <a:t>200 </a:t>
                       </a:r>
                       <a:endParaRPr lang="en-US" sz="2400" b="0" u="none" strike="noStrike" dirty="0">
                         <a:solidFill>
@@ -22204,7 +22204,7 @@
                           <a:latin typeface="Arial"/>
                           <a:ea typeface="Arial"/>
                         </a:rPr>
-                        <a:t>200</a:t>
+                        <a:t>100</a:t>
                       </a:r>
                       <a:r>
                         <a:rPr lang="en" sz="2400" b="0" u="none" strike="noStrike" dirty="0">

</xml_diff>